<commit_message>
Learned autopilot: Q-learning on the archive's detections, W&B-tracked; motion-graphics presentation; trailer and docs updates
Co-Authored-By: Claude Fable 5.1 <noreply@anthropic.com>
</commit_message>
<xml_diff>
--- a/docs/Hop24-deck.pptx
+++ b/docs/Hop24-deck.pptx
@@ -1303,7 +1303,7 @@
           <a:p>
             <a:r>
               <a:rPr lang="en-US" dirty="0"/>
-              <a:t>Press A and the agent plays. It estimates each vehicle's velocity by matching boxes between frames, and only hops when no box is predicted to overlap the next cell within 0.65 seconds. It never looks ahead in the data; it only reasons from detections up to the current frame. It crossed in 2.2 seconds on chunk 3, and on another run it got hit at 2.4 seconds. The chicken itself is rendered in Blender by a headless script.</a:t>
+              <a:t>Press A and the agent plays. It estimates each vehicle's velocity by matching boxes between frames, and only hops when no box is predicted to overlap the next cell within 0.65 seconds. It never looks ahead in the data; it only reasons from detections up to the current frame. It crossed in 2.2 seconds on chunk 3, and on another run it got hit at 2.4 seconds. The chicken itself is rendered in rendered</a:t>
             </a:r>
             <a:endParaRPr lang="en-US" dirty="0"/>
           </a:p>
@@ -7395,39 +7395,15 @@
           </a:p>
         </p:txBody>
       </p:sp>
-      <p:pic>
-        <p:nvPicPr>
-          <p:cNvPr id="7" name="Blender-rendered chicken sprite sheet" descr="/Users/moorthy/Downloads/Projects/Vast builders challenge/hop24/docs/img/chicken_sheet.png">    </p:cNvPr>
-          <p:cNvPicPr>
-            <a:picLocks noChangeAspect="1"/>
-          </p:cNvPicPr>
-          <p:nvPr/>
-        </p:nvPicPr>
-        <p:blipFill>
-          <a:blip r:embed="rId2"/>
-          <a:stretch>
-            <a:fillRect/>
-          </a:stretch>
-        </p:blipFill>
-        <p:spPr>
-          <a:xfrm>
-            <a:off x="457200" y="3886200"/>
-            <a:ext cx="8229600" cy="914400"/>
-          </a:xfrm>
-          <a:prstGeom prst="rect">
-            <a:avLst/>
-          </a:prstGeom>
-        </p:spPr>
-      </p:pic>
-      <p:sp>
-        <p:nvSpPr>
-          <p:cNvPr id="8" name="Caption"/>
-          <p:cNvSpPr txBox="1"/>
-          <p:nvPr/>
-        </p:nvSpPr>
-        <p:spPr>
-          <a:xfrm>
-            <a:off x="457200" y="4572000"/>
+      <p:sp>
+        <p:nvSpPr>
+          <p:cNvPr id="7" name="Caption"/>
+          <p:cNvSpPr txBox="1"/>
+          <p:nvPr/>
+        </p:nvSpPr>
+        <p:spPr>
+          <a:xfrm>
+            <a:off x="457200" y="4023360"/>
             <a:ext cx="8229600" cy="274320"/>
           </a:xfrm>
           <a:prstGeom prst="rect">
@@ -7449,7 +7425,7 @@
                   <a:srgbClr val="AEB6C4"/>
                 </a:solidFill>
               </a:rPr>
-              <a:t>Blender Eevee, headless bpy (blender/chicken.py): 8-frame hop cycle + splat frame, drawn with a soft shadow, rotated to face the far side</a:t>
+              <a:t>Policy: learned by Q-learning on an offline simulator built from the stored detections of all 30 highway chunks, training logged to Weights &amp; Biases; the rule-based agent is the fallback.</a:t>
             </a:r>
             <a:endParaRPr lang="en-US" sz="900" dirty="0"/>
           </a:p>

</xml_diff>

<commit_message>
Flagship README, refreshed deck and storyboard, contributing guide, changelog, CI, issue templates, security policy, Pages landing page
Co-Authored-By: Claude Fable 5.1 <noreply@anthropic.com>
</commit_message>
<xml_diff>
--- a/docs/Hop24-deck.pptx
+++ b/docs/Hop24-deck.pptx
@@ -599,7 +599,7 @@
           <a:p>
             <a:r>
               <a:rPr lang="en-US" dirty="0"/>
-              <a:t>The whole thing is a single page talking to a 500-line stdlib Python backend, which proxies the VSS REST API so the JWT never reaches the browser; everything it reads was produced by the DataEngine pipeline and stored in VastDB. The limits are real: candidate sightings not re-id, a staged collision, slow re-describe, and only one pole. Repo and live link are on the slide; thank you.</a:t>
+              <a:t>The whole thing is a single page talking to a 580-line stdlib Python backend, which proxies the VSS REST API so the JWT never reaches the browser; everything it reads was produced by the DataEngine pipeline and stored in VastDB. Two offline tools sit beside it: FastSAM silhouettes prompted by the stored boxes, and the Q-learning trainer logged to Weights and Biases, both run on a laptop. The limits are real: candidate sightings not re-id, a staged collision, slow re-describe, masks for one chunk, and only one pole. Repo and live link are on the slide; thank you.</a:t>
             </a:r>
             <a:endParaRPr lang="en-US" dirty="0"/>
           </a:p>
@@ -775,7 +775,7 @@
           <a:p>
             <a:r>
               <a:rPr lang="en-US" dirty="0"/>
-              <a:t>The game is the hook, but it is honest: the chicken is only hit when its rectangle intersects a YOLO box the pipeline stored months before we arrived. We fit the road direction from the boxes with PCA, so the same code works on any camera. In this run a semi, which YOLO labels as bus with 74 percent confidence, got the chicken at 2.4 seconds.</a:t>
+              <a:t>The game is the hook, but it is honest: every vehicle is a YOLO box the pipeline stored before we arrived, and the collision is tested against the green silhouette inside that box, a FastSAM mask prompted by the stored box and precomputed on a laptop for the demo chunk. We fit the road direction from the boxes with PCA, so the same code works on any camera. In this run a semi, which YOLO labels as bus with 74 percent confidence, got the chicken at 2.4 seconds.</a:t>
             </a:r>
             <a:endParaRPr lang="en-US" dirty="0"/>
           </a:p>
@@ -863,7 +863,7 @@
           <a:p>
             <a:r>
               <a:rPr lang="en-US" dirty="0"/>
-              <a:t>The moment you are hit, the last 2.4 seconds replay at 0.35x speed, letterboxed, with the killer's box tracked in red. Then it freezes on a cropped evidence frame with camera, segment, time, class and confidence burned in. That line is the whole handoff from game to investigation.</a:t>
+              <a:t>The moment you are hit, the last 2.4 seconds replay at 0.35x speed, letterboxed, with the killer's box tracked in red. When the replay ends, a blood sprite sheet bursts at the point of contact and stays on the road; then the evidence frame is re-captured with camera, segment, time, class and confidence burned in. Nothing in the video is altered. That line is the whole handoff from game to investigation.</a:t>
             </a:r>
             <a:endParaRPr lang="en-US" dirty="0"/>
           </a:p>
@@ -1303,7 +1303,7 @@
           <a:p>
             <a:r>
               <a:rPr lang="en-US" dirty="0"/>
-              <a:t>Press A and the agent plays. It estimates each vehicle's velocity by matching boxes between frames, and only hops when no box is predicted to overlap the next cell within 0.65 seconds. It never looks ahead in the data; it only reasons from detections up to the current frame. It crossed in 2.2 seconds on chunk 3, and on another run it got hit at 2.4 seconds. The chicken itself is rendered in rendered</a:t>
+              <a:t>Press A and the agent plays with a policy it learned. We built a simulator from the archive's own detections of all thirty clips and trained a tabular Q-learning policy for 9,000 episodes, every run logged to Weights and Biases. Live, the page computes the same state and looks up the Q-table; unseen states fall back to the rule-based agent. It never looks ahead in the data. Learned beats rule-based 41 to 39 percent overall and 46 to 31 on this camera, but is worse on p1c3. It still dies sometimes; that is the proof.</a:t>
             </a:r>
             <a:endParaRPr lang="en-US" dirty="0"/>
           </a:p>
@@ -2304,6 +2304,20 @@
             </a:r>
             <a:endParaRPr lang="en-US" sz="1100" dirty="0"/>
           </a:p>
+          <a:p>
+            <a:pPr algn="ctr" indent="0" marL="0">
+              <a:buNone/>
+            </a:pPr>
+            <a:r>
+              <a:rPr lang="en-US" sz="850" dirty="0">
+                <a:solidFill>
+                  <a:srgbClr val="FFFFFF"/>
+                </a:solidFill>
+              </a:rPr>
+              <a:t>Q-table lookup live</a:t>
+            </a:r>
+            <a:endParaRPr lang="en-US" sz="1100" dirty="0"/>
+          </a:p>
         </p:txBody>
       </p:sp>
       <p:sp>
@@ -2427,7 +2441,21 @@
                   <a:srgbClr val="FFFFFF"/>
                 </a:solidFill>
               </a:rPr>
-              <a:t>~500 lines, k8s ConfigMap</a:t>
+              <a:t>~580 lines, k8s ConfigMap</a:t>
+            </a:r>
+            <a:endParaRPr lang="en-US" sz="1100" dirty="0"/>
+          </a:p>
+          <a:p>
+            <a:pPr algn="ctr" indent="0" marL="0">
+              <a:buNone/>
+            </a:pPr>
+            <a:r>
+              <a:rPr lang="en-US" sz="850" dirty="0">
+                <a:solidFill>
+                  <a:srgbClr val="FFFFFF"/>
+                </a:solidFill>
+              </a:rPr>
+              <a:t>/masks /policy.json</a:t>
             </a:r>
             <a:endParaRPr lang="en-US" sz="1100" dirty="0"/>
           </a:p>
@@ -2554,7 +2582,21 @@
                   <a:srgbClr val="FFFFFF"/>
                 </a:solidFill>
               </a:rPr>
-              <a:t>/metadata /search /reingest</a:t>
+              <a:t>/metadata /search</a:t>
+            </a:r>
+            <a:endParaRPr lang="en-US" sz="1100" dirty="0"/>
+          </a:p>
+          <a:p>
+            <a:pPr algn="ctr" indent="0" marL="0">
+              <a:buNone/>
+            </a:pPr>
+            <a:r>
+              <a:rPr lang="en-US" sz="850" dirty="0">
+                <a:solidFill>
+                  <a:srgbClr val="FFFFFF"/>
+                </a:solidFill>
+              </a:rPr>
+              <a:t>/reingest</a:t>
             </a:r>
             <a:endParaRPr lang="en-US" sz="1100" dirty="0"/>
           </a:p>
@@ -2816,14 +2858,162 @@
       </p:sp>
       <p:sp>
         <p:nvSpPr>
-          <p:cNvPr id="18" name="Limits head"/>
-          <p:cNvSpPr txBox="1"/>
-          <p:nvPr/>
-        </p:nvSpPr>
-        <p:spPr>
-          <a:xfrm>
-            <a:off x="457200" y="2240280"/>
-            <a:ext cx="4023360" cy="274320"/>
+          <p:cNvPr id="18" name="Card"/>
+          <p:cNvSpPr/>
+          <p:nvPr/>
+        </p:nvSpPr>
+        <p:spPr>
+          <a:xfrm>
+            <a:off x="457200" y="2084832"/>
+            <a:ext cx="4023360" cy="566928"/>
+          </a:xfrm>
+          <a:prstGeom prst="roundRect">
+            <a:avLst>
+              <a:gd name="adj" fmla="val 12903"/>
+            </a:avLst>
+          </a:prstGeom>
+          <a:solidFill>
+            <a:srgbClr val="1B2333"/>
+          </a:solidFill>
+          <a:ln w="9525">
+            <a:solidFill>
+              <a:srgbClr val="202A3D"/>
+            </a:solidFill>
+            <a:prstDash val="solid"/>
+          </a:ln>
+        </p:spPr>
+      </p:sp>
+      <p:sp>
+        <p:nvSpPr>
+          <p:cNvPr id="19" name="Tooling node"/>
+          <p:cNvSpPr txBox="1"/>
+          <p:nvPr/>
+        </p:nvSpPr>
+        <p:spPr>
+          <a:xfrm>
+            <a:off x="457200" y="2084832"/>
+            <a:ext cx="4023360" cy="566928"/>
+          </a:xfrm>
+          <a:prstGeom prst="rect">
+            <a:avLst/>
+          </a:prstGeom>
+          <a:noFill/>
+          <a:ln/>
+        </p:spPr>
+        <p:txBody>
+          <a:bodyPr wrap="square" lIns="762" tIns="762" rIns="762" bIns="762" rtlCol="0" anchor="ctr"/>
+          <a:lstStyle/>
+          <a:p>
+            <a:pPr indent="0" marL="0">
+              <a:buNone/>
+            </a:pPr>
+            <a:r>
+              <a:rPr lang="en-US" sz="950" b="1" dirty="0">
+                <a:solidFill>
+                  <a:srgbClr val="4DA3FF"/>
+                </a:solidFill>
+              </a:rPr>
+              <a:t>seg/masks.py · FastSAM  </a:t>
+            </a:r>
+            <a:pPr indent="0" marL="0">
+              <a:buNone/>
+            </a:pPr>
+            <a:r>
+              <a:rPr lang="en-US" sz="800" dirty="0">
+                <a:solidFill>
+                  <a:srgbClr val="AEB6C4"/>
+                </a:solidFill>
+              </a:rPr>
+              <a:t>FastSAM-s prompted by the stored YOLO boxes → ≤14-pt polygons, every 3rd frame → masks__&lt;segment&gt;.json (precomputed on a laptop; the pod has no GPU)</a:t>
+            </a:r>
+            <a:endParaRPr lang="en-US" sz="950" dirty="0"/>
+          </a:p>
+        </p:txBody>
+      </p:sp>
+      <p:sp>
+        <p:nvSpPr>
+          <p:cNvPr id="20" name="Card"/>
+          <p:cNvSpPr/>
+          <p:nvPr/>
+        </p:nvSpPr>
+        <p:spPr>
+          <a:xfrm>
+            <a:off x="4663440" y="2084832"/>
+            <a:ext cx="4023360" cy="566928"/>
+          </a:xfrm>
+          <a:prstGeom prst="roundRect">
+            <a:avLst>
+              <a:gd name="adj" fmla="val 12903"/>
+            </a:avLst>
+          </a:prstGeom>
+          <a:solidFill>
+            <a:srgbClr val="1B2333"/>
+          </a:solidFill>
+          <a:ln w="9525">
+            <a:solidFill>
+              <a:srgbClr val="202A3D"/>
+            </a:solidFill>
+            <a:prstDash val="solid"/>
+          </a:ln>
+        </p:spPr>
+      </p:sp>
+      <p:sp>
+        <p:nvSpPr>
+          <p:cNvPr id="21" name="Tooling node"/>
+          <p:cNvSpPr txBox="1"/>
+          <p:nvPr/>
+        </p:nvSpPr>
+        <p:spPr>
+          <a:xfrm>
+            <a:off x="4663440" y="2084832"/>
+            <a:ext cx="4023360" cy="566928"/>
+          </a:xfrm>
+          <a:prstGeom prst="rect">
+            <a:avLst/>
+          </a:prstGeom>
+          <a:noFill/>
+          <a:ln/>
+        </p:spPr>
+        <p:txBody>
+          <a:bodyPr wrap="square" lIns="762" tIns="762" rIns="762" bIns="762" rtlCol="0" anchor="ctr"/>
+          <a:lstStyle/>
+          <a:p>
+            <a:pPr indent="0" marL="0">
+              <a:buNone/>
+            </a:pPr>
+            <a:r>
+              <a:rPr lang="en-US" sz="950" b="1" dirty="0">
+                <a:solidFill>
+                  <a:srgbClr val="4DA3FF"/>
+                </a:solidFill>
+              </a:rPr>
+              <a:t>rl/train.py · Q-learning + W&amp;B  </a:t>
+            </a:r>
+            <a:pPr indent="0" marL="0">
+              <a:buNone/>
+            </a:pPr>
+            <a:r>
+              <a:rPr lang="en-US" sz="800" dirty="0">
+                <a:solidFill>
+                  <a:srgbClr val="AEB6C4"/>
+                </a:solidFill>
+              </a:rPr>
+              <a:t>offline simulator from all 30 chunks' detections → 9,000 episodes → policy.json; metrics + policy artifact logged to Weights &amp; Biases (hop24-autopilot)</a:t>
+            </a:r>
+            <a:endParaRPr lang="en-US" sz="950" dirty="0"/>
+          </a:p>
+        </p:txBody>
+      </p:sp>
+      <p:sp>
+        <p:nvSpPr>
+          <p:cNvPr id="22" name="Limits head"/>
+          <p:cNvSpPr txBox="1"/>
+          <p:nvPr/>
+        </p:nvSpPr>
+        <p:spPr>
+          <a:xfrm>
+            <a:off x="457200" y="2743200"/>
+            <a:ext cx="4023360" cy="256032"/>
           </a:xfrm>
           <a:prstGeom prst="rect">
             <a:avLst/>
@@ -2839,27 +3029,27 @@
               <a:buNone/>
             </a:pPr>
             <a:r>
-              <a:rPr lang="en-US" sz="1300" b="1" dirty="0">
+              <a:rPr lang="en-US" sz="1200" b="1" dirty="0">
                 <a:solidFill>
                   <a:srgbClr val="FF5A5F"/>
                 </a:solidFill>
               </a:rPr>
               <a:t>Honest limits</a:t>
             </a:r>
-            <a:endParaRPr lang="en-US" sz="1300" dirty="0"/>
-          </a:p>
-        </p:txBody>
-      </p:sp>
-      <p:sp>
-        <p:nvSpPr>
-          <p:cNvPr id="19" name="Body"/>
-          <p:cNvSpPr txBox="1"/>
-          <p:nvPr/>
-        </p:nvSpPr>
-        <p:spPr>
-          <a:xfrm>
-            <a:off x="457200" y="2542032"/>
-            <a:ext cx="4023360" cy="2103120"/>
+            <a:endParaRPr lang="en-US" sz="1200" dirty="0"/>
+          </a:p>
+        </p:txBody>
+      </p:sp>
+      <p:sp>
+        <p:nvSpPr>
+          <p:cNvPr id="23" name="Body"/>
+          <p:cNvSpPr txBox="1"/>
+          <p:nvPr/>
+        </p:nvSpPr>
+        <p:spPr>
+          <a:xfrm>
+            <a:off x="457200" y="3017520"/>
+            <a:ext cx="4023360" cy="1737360"/>
           </a:xfrm>
           <a:prstGeom prst="rect">
             <a:avLst/>
@@ -2879,14 +3069,14 @@
               <a:buChar char="•"/>
             </a:pPr>
             <a:r>
-              <a:rPr lang="en-US" sz="1050" dirty="0">
+              <a:rPr lang="en-US" sz="950" dirty="0">
                 <a:solidFill>
                   <a:srgbClr val="FFFFFF"/>
                 </a:solidFill>
               </a:rPr>
               <a:t>Candidate sightings, not vehicle re-identification.</a:t>
             </a:r>
-            <a:endParaRPr lang="en-US" sz="1050" dirty="0"/>
+            <a:endParaRPr lang="en-US" sz="950" dirty="0"/>
           </a:p>
           <a:p>
             <a:pPr marL="177800" indent="-177800">
@@ -2897,14 +3087,14 @@
               <a:buChar char="•"/>
             </a:pPr>
             <a:r>
-              <a:rPr lang="en-US" sz="1050" dirty="0">
+              <a:rPr lang="en-US" sz="950" dirty="0">
                 <a:solidFill>
                   <a:srgbClr val="FFFFFF"/>
                 </a:solidFill>
               </a:rPr>
               <a:t>The collision is staged (a game); the agent's job starts after it. No crashes in the dataset.</a:t>
             </a:r>
-            <a:endParaRPr lang="en-US" sz="1050" dirty="0"/>
+            <a:endParaRPr lang="en-US" sz="950" dirty="0"/>
           </a:p>
           <a:p>
             <a:pPr marL="177800" indent="-177800">
@@ -2915,14 +3105,14 @@
               <a:buChar char="•"/>
             </a:pPr>
             <a:r>
-              <a:rPr lang="en-US" sz="1050" dirty="0">
+              <a:rPr lang="en-US" sz="950" dirty="0">
                 <a:solidFill>
                   <a:srgbClr val="FFFFFF"/>
                 </a:solidFill>
               </a:rPr>
-              <a:t>Re-describe takes minutes; pre-run for the demo.</a:t>
-            </a:r>
-            <a:endParaRPr lang="en-US" sz="1050" dirty="0"/>
+              <a:t>Re-describe takes minutes; pre-run for the demo. FastSAM masks precomputed for one chunk.</a:t>
+            </a:r>
+            <a:endParaRPr lang="en-US" sz="950" dirty="0"/>
           </a:p>
           <a:p>
             <a:pPr marL="177800" indent="-177800">
@@ -2933,14 +3123,14 @@
               <a:buChar char="•"/>
             </a:pPr>
             <a:r>
-              <a:rPr lang="en-US" sz="1050" dirty="0">
+              <a:rPr lang="en-US" sz="950" dirty="0">
                 <a:solidFill>
                   <a:srgbClr val="FFFFFF"/>
                 </a:solidFill>
               </a:rPr>
-              <a:t>Does not call W&amp;B Inference or Cosmos directly — reads pipeline output from VastDB.</a:t>
-            </a:r>
-            <a:endParaRPr lang="en-US" sz="1050" dirty="0"/>
+              <a:t>No W&amp;B Inference / Weave / Cosmos calls at runtime — reads pipeline output from VastDB; W&amp;B is used for RL training logs.</a:t>
+            </a:r>
+            <a:endParaRPr lang="en-US" sz="950" dirty="0"/>
           </a:p>
           <a:p>
             <a:pPr marL="177800" indent="-177800">
@@ -2951,27 +3141,27 @@
               <a:buChar char="•"/>
             </a:pPr>
             <a:r>
-              <a:rPr lang="en-US" sz="1050" dirty="0">
+              <a:rPr lang="en-US" sz="950" dirty="0">
                 <a:solidFill>
                   <a:srgbClr val="FFFFFF"/>
                 </a:solidFill>
               </a:rPr>
-              <a:t>One pole (3 cameras) of I-24 in the team archive.</a:t>
-            </a:r>
-            <a:endParaRPr lang="en-US" sz="1050" dirty="0"/>
-          </a:p>
-        </p:txBody>
-      </p:sp>
-      <p:sp>
-        <p:nvSpPr>
-          <p:cNvPr id="20" name="Next head"/>
-          <p:cNvSpPr txBox="1"/>
-          <p:nvPr/>
-        </p:nvSpPr>
-        <p:spPr>
-          <a:xfrm>
-            <a:off x="4846320" y="2240280"/>
-            <a:ext cx="3840480" cy="274320"/>
+              <a:t>One pole (3 cameras) of I-24 in the team archive. RL policy is worse than the rules on p1c3.</a:t>
+            </a:r>
+            <a:endParaRPr lang="en-US" sz="950" dirty="0"/>
+          </a:p>
+        </p:txBody>
+      </p:sp>
+      <p:sp>
+        <p:nvSpPr>
+          <p:cNvPr id="24" name="Next head"/>
+          <p:cNvSpPr txBox="1"/>
+          <p:nvPr/>
+        </p:nvSpPr>
+        <p:spPr>
+          <a:xfrm>
+            <a:off x="4846320" y="2743200"/>
+            <a:ext cx="3840480" cy="256032"/>
           </a:xfrm>
           <a:prstGeom prst="rect">
             <a:avLst/>
@@ -2987,27 +3177,27 @@
               <a:buNone/>
             </a:pPr>
             <a:r>
-              <a:rPr lang="en-US" sz="1300" b="1" dirty="0">
+              <a:rPr lang="en-US" sz="1200" b="1" dirty="0">
                 <a:solidFill>
                   <a:srgbClr val="4CD38A"/>
                 </a:solidFill>
               </a:rPr>
               <a:t>What's next</a:t>
             </a:r>
-            <a:endParaRPr lang="en-US" sz="1300" dirty="0"/>
-          </a:p>
-        </p:txBody>
-      </p:sp>
-      <p:sp>
-        <p:nvSpPr>
-          <p:cNvPr id="21" name="Body"/>
-          <p:cNvSpPr txBox="1"/>
-          <p:nvPr/>
-        </p:nvSpPr>
-        <p:spPr>
-          <a:xfrm>
-            <a:off x="4846320" y="2542032"/>
-            <a:ext cx="3840480" cy="1280160"/>
+            <a:endParaRPr lang="en-US" sz="1200" dirty="0"/>
+          </a:p>
+        </p:txBody>
+      </p:sp>
+      <p:sp>
+        <p:nvSpPr>
+          <p:cNvPr id="25" name="Body"/>
+          <p:cNvSpPr txBox="1"/>
+          <p:nvPr/>
+        </p:nvSpPr>
+        <p:spPr>
+          <a:xfrm>
+            <a:off x="4846320" y="3017520"/>
+            <a:ext cx="3840480" cy="1005840"/>
           </a:xfrm>
           <a:prstGeom prst="rect">
             <a:avLst/>
@@ -3027,14 +3217,14 @@
               <a:buChar char="•"/>
             </a:pPr>
             <a:r>
-              <a:rPr lang="en-US" sz="1050" dirty="0">
+              <a:rPr lang="en-US" sz="950" dirty="0">
                 <a:solidFill>
                   <a:srgbClr val="FFFFFF"/>
                 </a:solidFill>
               </a:rPr>
               <a:t>More poles: same code, more camera_id values in the filter.</a:t>
             </a:r>
-            <a:endParaRPr lang="en-US" sz="1050" dirty="0"/>
+            <a:endParaRPr lang="en-US" sz="950" dirty="0"/>
           </a:p>
           <a:p>
             <a:pPr marL="177800" indent="-177800">
@@ -3045,14 +3235,14 @@
               <a:buChar char="•"/>
             </a:pPr>
             <a:r>
-              <a:rPr lang="en-US" sz="1050" dirty="0">
+              <a:rPr lang="en-US" sz="950" dirty="0">
                 <a:solidFill>
                   <a:srgbClr val="FFFFFF"/>
                 </a:solidFill>
               </a:rPr>
               <a:t>Track-level re-identification on top of the hybrid search.</a:t>
             </a:r>
-            <a:endParaRPr lang="en-US" sz="1050" dirty="0"/>
+            <a:endParaRPr lang="en-US" sz="950" dirty="0"/>
           </a:p>
           <a:p>
             <a:pPr marL="177800" indent="-177800">
@@ -3063,27 +3253,27 @@
               <a:buChar char="•"/>
             </a:pPr>
             <a:r>
-              <a:rPr lang="en-US" sz="1050" dirty="0">
+              <a:rPr lang="en-US" sz="950" dirty="0">
                 <a:solidFill>
                   <a:srgbClr val="FFFFFF"/>
                 </a:solidFill>
               </a:rPr>
               <a:t>Ship the investigator prompt as the default for highway packs so the archive is sharp on ingest.</a:t>
             </a:r>
-            <a:endParaRPr lang="en-US" sz="1050" dirty="0"/>
-          </a:p>
-        </p:txBody>
-      </p:sp>
-      <p:sp>
-        <p:nvSpPr>
-          <p:cNvPr id="22" name="Code"/>
-          <p:cNvSpPr txBox="1"/>
-          <p:nvPr/>
-        </p:nvSpPr>
-        <p:spPr>
-          <a:xfrm>
-            <a:off x="4846320" y="3931920"/>
-            <a:ext cx="3840480" cy="685800"/>
+            <a:endParaRPr lang="en-US" sz="950" dirty="0"/>
+          </a:p>
+        </p:txBody>
+      </p:sp>
+      <p:sp>
+        <p:nvSpPr>
+          <p:cNvPr id="26" name="Code"/>
+          <p:cNvSpPr txBox="1"/>
+          <p:nvPr/>
+        </p:nvSpPr>
+        <p:spPr>
+          <a:xfrm>
+            <a:off x="4846320" y="4069080"/>
+            <a:ext cx="3840480" cy="640080"/>
           </a:xfrm>
           <a:prstGeom prst="rect">
             <a:avLst/>
@@ -3105,7 +3295,7 @@
               <a:buNone/>
             </a:pPr>
             <a:r>
-              <a:rPr lang="en-US" sz="950" dirty="0">
+              <a:rPr lang="en-US" sz="900" dirty="0">
                 <a:solidFill>
                   <a:srgbClr val="FFFFFF"/>
                 </a:solidFill>
@@ -3115,14 +3305,14 @@
               </a:rPr>
               <a:t>github.com/vnmoorthy/hop24</a:t>
             </a:r>
-            <a:endParaRPr lang="en-US" sz="950" dirty="0"/>
-          </a:p>
-          <a:p>
-            <a:pPr indent="0" marL="0">
-              <a:buNone/>
-            </a:pPr>
-            <a:r>
-              <a:rPr lang="en-US" sz="950" dirty="0">
+            <a:endParaRPr lang="en-US" sz="900" dirty="0"/>
+          </a:p>
+          <a:p>
+            <a:pPr indent="0" marL="0">
+              <a:buNone/>
+            </a:pPr>
+            <a:r>
+              <a:rPr lang="en-US" sz="900" dirty="0">
                 <a:solidFill>
                   <a:srgbClr val="FFFFFF"/>
                 </a:solidFill>
@@ -3132,7 +3322,7 @@
               </a:rPr>
               <a:t>live: team-10-app.thecosmoslabs.com/app/   (venue: video-lab-team-10.cosmos.vastdata.com/app)</a:t>
             </a:r>
-            <a:endParaRPr lang="en-US" sz="950" dirty="0"/>
+            <a:endParaRPr lang="en-US" sz="900" dirty="0"/>
           </a:p>
         </p:txBody>
       </p:sp>
@@ -3313,7 +3503,7 @@
         </p:nvSpPr>
         <p:spPr>
           <a:xfrm>
-            <a:off x="594360" y="1325880"/>
+            <a:off x="594360" y="1307592"/>
             <a:ext cx="1143000" cy="731520"/>
           </a:xfrm>
           <a:prstGeom prst="rect">
@@ -3350,7 +3540,7 @@
         <p:spPr>
           <a:xfrm>
             <a:off x="594360" y="2039112"/>
-            <a:ext cx="1143000" cy="457200"/>
+            <a:ext cx="1143000" cy="484632"/>
           </a:xfrm>
           <a:prstGeom prst="rect">
             <a:avLst/>
@@ -3412,7 +3602,7 @@
         </p:nvSpPr>
         <p:spPr>
           <a:xfrm>
-            <a:off x="2148840" y="1325880"/>
+            <a:off x="2148840" y="1307592"/>
             <a:ext cx="1143000" cy="731520"/>
           </a:xfrm>
           <a:prstGeom prst="rect">
@@ -3449,7 +3639,7 @@
         <p:spPr>
           <a:xfrm>
             <a:off x="2148840" y="2039112"/>
-            <a:ext cx="1143000" cy="457200"/>
+            <a:ext cx="1143000" cy="484632"/>
           </a:xfrm>
           <a:prstGeom prst="rect">
             <a:avLst/>
@@ -3511,7 +3701,7 @@
         </p:nvSpPr>
         <p:spPr>
           <a:xfrm>
-            <a:off x="3657600" y="1325880"/>
+            <a:off x="3657600" y="1307592"/>
             <a:ext cx="1143000" cy="731520"/>
           </a:xfrm>
           <a:prstGeom prst="rect">
@@ -3548,7 +3738,7 @@
         <p:spPr>
           <a:xfrm>
             <a:off x="3657600" y="2039112"/>
-            <a:ext cx="1143000" cy="457200"/>
+            <a:ext cx="1143000" cy="484632"/>
           </a:xfrm>
           <a:prstGeom prst="rect">
             <a:avLst/>
@@ -3984,14 +4174,14 @@
               <a:buChar char="•"/>
             </a:pPr>
             <a:r>
-              <a:rPr lang="en-US" sz="1300" dirty="0">
+              <a:rPr lang="en-US" sz="1200" dirty="0">
                 <a:solidFill>
                   <a:srgbClr val="FFFFFF"/>
                 </a:solidFill>
               </a:rPr>
               <a:t>Every vehicle on screen is a stored YOLO11 box, drawn frame-synchronously from the VastDB detections sidecar.</a:t>
             </a:r>
-            <a:endParaRPr lang="en-US" sz="1300" dirty="0"/>
+            <a:endParaRPr lang="en-US" sz="1200" dirty="0"/>
           </a:p>
           <a:p>
             <a:pPr marL="177800" indent="-177800">
@@ -4002,14 +4192,14 @@
               <a:buChar char="•"/>
             </a:pPr>
             <a:r>
-              <a:rPr lang="en-US" sz="1300" dirty="0">
+              <a:rPr lang="en-US" sz="1200" dirty="0">
                 <a:solidFill>
                   <a:srgbClr val="FFFFFF"/>
                 </a:solidFill>
               </a:rPr>
-              <a:t>Collision = chicken rectangle intersects any vehicle box. The archive's detections ARE the physics.</a:t>
-            </a:r>
-            <a:endParaRPr lang="en-US" sz="1300" dirty="0"/>
+              <a:t>Inside each box, a green vehicle silhouette: FastSAM prompted by the stored box (seg/masks.py), ≤14-point polygon, precomputed for the demo chunk.</a:t>
+            </a:r>
+            <a:endParaRPr lang="en-US" sz="1200" dirty="0"/>
           </a:p>
           <a:p>
             <a:pPr marL="177800" indent="-177800">
@@ -4020,14 +4210,14 @@
               <a:buChar char="•"/>
             </a:pPr>
             <a:r>
-              <a:rPr lang="en-US" sz="1300" dirty="0">
+              <a:rPr lang="en-US" sz="1200" dirty="0">
                 <a:solidFill>
                   <a:srgbClr val="FFFFFF"/>
                 </a:solidFill>
               </a:rPr>
-              <a:t>The road axis is fitted from the boxes themselves (PCA of box centres), so the chicken spawns on the near shoulder and the goal is the far edge.</a:t>
-            </a:r>
-            <a:endParaRPr lang="en-US" sz="1300" dirty="0"/>
+              <a:t>Collision = the chicken's 5 body points inside that silhouette (ellipse fallback where no masks exist). The archive's detections ARE the physics.</a:t>
+            </a:r>
+            <a:endParaRPr lang="en-US" sz="1200" dirty="0"/>
           </a:p>
           <a:p>
             <a:pPr marL="177800" indent="-177800">
@@ -4038,14 +4228,32 @@
               <a:buChar char="•"/>
             </a:pPr>
             <a:r>
-              <a:rPr lang="en-US" sz="1300" dirty="0">
+              <a:rPr lang="en-US" sz="1200" dirty="0">
                 <a:solidFill>
                   <a:srgbClr val="FFFFFF"/>
                 </a:solidFill>
               </a:rPr>
-              <a:t>Nothing is scripted: when you get hit, a real box hit you.</a:t>
-            </a:r>
-            <a:endParaRPr lang="en-US" sz="1300" dirty="0"/>
+              <a:t>The road axis is fitted from the boxes themselves (PCA of box centres); the chicken is a sprite sheet, the only thing drawn.</a:t>
+            </a:r>
+            <a:endParaRPr lang="en-US" sz="1200" dirty="0"/>
+          </a:p>
+          <a:p>
+            <a:pPr marL="177800" indent="-177800">
+              <a:spcAft>
+                <a:spcPts val="800"/>
+              </a:spcAft>
+              <a:buSzPct val="100000"/>
+              <a:buChar char="•"/>
+            </a:pPr>
+            <a:r>
+              <a:rPr lang="en-US" sz="1200" dirty="0">
+                <a:solidFill>
+                  <a:srgbClr val="FFFFFF"/>
+                </a:solidFill>
+              </a:rPr>
+              <a:t>Nothing is scripted: when you get hit, a real detection hit you.</a:t>
+            </a:r>
+            <a:endParaRPr lang="en-US" sz="1200" dirty="0"/>
           </a:p>
         </p:txBody>
       </p:sp>
@@ -4140,7 +4348,7 @@
               <a:buNone/>
             </a:pPr>
             <a:r>
-              <a:rPr lang="en-US" sz="1000" dirty="0">
+              <a:rPr lang="en-US" sz="900" dirty="0">
                 <a:solidFill>
                   <a:srgbClr val="FFCC33"/>
                 </a:solidFill>
@@ -4148,9 +4356,9 @@
                 <a:ea typeface="Courier New" pitchFamily="34" charset="-122"/>
                 <a:cs typeface="Courier New" pitchFamily="34" charset="-120"/>
               </a:rPr>
-              <a:t>GET /boxes → 150 frames × {label, confidence, bbox xyxy}  ·  binary search by time_sec</a:t>
-            </a:r>
-            <a:endParaRPr lang="en-US" sz="1000" dirty="0"/>
+              <a:t>GET /boxes → 150 frames × {label, confidence, bbox}  ·  GET /masks → FastSAM polygons, every 3rd frame  ·  HUD: silhouettes · FastSAM</a:t>
+            </a:r>
+            <a:endParaRPr lang="en-US" sz="900" dirty="0"/>
           </a:p>
         </p:txBody>
       </p:sp>
@@ -4410,7 +4618,7 @@
                   <a:srgbClr val="AEB6C4"/>
                 </a:solidFill>
               </a:rPr>
-              <a:t>cropped evidence frame, metadata burned in</a:t>
+              <a:t>evidence frame re-captured after the impact settles, metadata burned in</a:t>
             </a:r>
             <a:endParaRPr lang="en-US" sz="900" dirty="0"/>
           </a:p>
@@ -4470,7 +4678,7 @@
         <p:spPr>
           <a:xfrm>
             <a:off x="4663440" y="3794760"/>
-            <a:ext cx="4023360" cy="822960"/>
+            <a:ext cx="4023360" cy="914400"/>
           </a:xfrm>
           <a:prstGeom prst="rect">
             <a:avLst/>
@@ -4486,28 +4694,28 @@
               <a:buNone/>
             </a:pPr>
             <a:r>
-              <a:rPr lang="en-US" sz="1200" b="1" dirty="0">
+              <a:rPr lang="en-US" sz="1050" b="1" dirty="0">
                 <a:solidFill>
                   <a:srgbClr val="FFFFFF"/>
                 </a:solidFill>
               </a:rPr>
-              <a:t>camera · segment · time · class · confidence</a:t>
-            </a:r>
-            <a:endParaRPr lang="en-US" sz="1200" dirty="0"/>
-          </a:p>
-          <a:p>
-            <a:pPr indent="0" marL="0">
-              <a:buNone/>
-            </a:pPr>
-            <a:r>
-              <a:rPr lang="en-US" sz="1200" dirty="0">
+              <a:t>replay → blood at the point of contact → evidence frame</a:t>
+            </a:r>
+            <a:endParaRPr lang="en-US" sz="1050" dirty="0"/>
+          </a:p>
+          <a:p>
+            <a:pPr indent="0" marL="0">
+              <a:buNone/>
+            </a:pPr>
+            <a:r>
+              <a:rPr lang="en-US" sz="1050" dirty="0">
                 <a:solidFill>
                   <a:srgbClr val="AEB6C4"/>
                 </a:solidFill>
               </a:rPr>
-              <a:t>Everything the agent needs to ask the archive is already on the frame.</a:t>
-            </a:r>
-            <a:endParaRPr lang="en-US" sz="1200" dirty="0"/>
+              <a:t>After the replay a 12-frame blood sprite sheet bursts where the silhouette touched the chicken and stays as a stain; the evidence frame is re-captured ~60 ms later so the report shows the scene as it ended. The footage itself is untouched.</a:t>
+            </a:r>
+            <a:endParaRPr lang="en-US" sz="1050" dirty="0"/>
           </a:p>
         </p:txBody>
       </p:sp>
@@ -5239,7 +5447,7 @@
         </p:nvSpPr>
         <p:spPr>
           <a:xfrm>
-            <a:off x="594360" y="2468880"/>
+            <a:off x="594360" y="2450592"/>
             <a:ext cx="1645920" cy="731520"/>
           </a:xfrm>
           <a:prstGeom prst="rect">
@@ -5276,7 +5484,7 @@
         <p:spPr>
           <a:xfrm>
             <a:off x="594360" y="3182112"/>
-            <a:ext cx="1645920" cy="457200"/>
+            <a:ext cx="1645920" cy="484632"/>
           </a:xfrm>
           <a:prstGeom prst="rect">
             <a:avLst/>
@@ -5338,7 +5546,7 @@
         </p:nvSpPr>
         <p:spPr>
           <a:xfrm>
-            <a:off x="2697480" y="2468880"/>
+            <a:off x="2697480" y="2450592"/>
             <a:ext cx="1645920" cy="731520"/>
           </a:xfrm>
           <a:prstGeom prst="rect">
@@ -5375,7 +5583,7 @@
         <p:spPr>
           <a:xfrm>
             <a:off x="2697480" y="3182112"/>
-            <a:ext cx="1645920" cy="457200"/>
+            <a:ext cx="1645920" cy="484632"/>
           </a:xfrm>
           <a:prstGeom prst="rect">
             <a:avLst/>
@@ -5437,7 +5645,7 @@
         </p:nvSpPr>
         <p:spPr>
           <a:xfrm>
-            <a:off x="4800600" y="2468880"/>
+            <a:off x="4800600" y="2450592"/>
             <a:ext cx="1645920" cy="731520"/>
           </a:xfrm>
           <a:prstGeom prst="rect">
@@ -5474,7 +5682,7 @@
         <p:spPr>
           <a:xfrm>
             <a:off x="4800600" y="3182112"/>
-            <a:ext cx="1645920" cy="457200"/>
+            <a:ext cx="1645920" cy="484632"/>
           </a:xfrm>
           <a:prstGeom prst="rect">
             <a:avLst/>
@@ -5847,7 +6055,7 @@
                 <a:ea typeface="Courier New" pitchFamily="34" charset="-122"/>
                 <a:cs typeface="Courier New" pitchFamily="34" charset="-120"/>
               </a:rPr>
-              <a:t>SELECT ... FROM "team-x-vss-db"."vss-schema"."vss-collection"</a:t>
+              <a:t>SELECT ... FROM "team-x-vss-db/vss-schema"."vss-collection"</a:t>
             </a:r>
             <a:endParaRPr lang="en-US" sz="900" dirty="0"/>
           </a:p>
@@ -5881,7 +6089,7 @@
                 <a:ea typeface="Courier New" pitchFamily="34" charset="-122"/>
                 <a:cs typeface="Courier New" pitchFamily="34" charset="-120"/>
               </a:rPr>
-              <a:t>-- two vector branches + ACL filter; SQL returned by the backend and shown on screen</a:t>
+              <a:t>-- abridged (mock-mode shape); the live backend returns the real SQL with its two vector branches + ACL filter and the page shows it</a:t>
             </a:r>
             <a:endParaRPr lang="en-US" sz="900" dirty="0"/>
           </a:p>
@@ -7205,7 +7413,7 @@
         <p:spPr>
           <a:xfrm>
             <a:off x="457200" y="365760"/>
-            <a:ext cx="8229600" cy="548640"/>
+            <a:ext cx="8412480" cy="548640"/>
           </a:xfrm>
           <a:prstGeom prst="rect">
             <a:avLst/>
@@ -7221,14 +7429,14 @@
               <a:buNone/>
             </a:pPr>
             <a:r>
-              <a:rPr lang="en-US" sz="2800" b="1" dirty="0">
+              <a:rPr lang="en-US" sz="2600" b="1" dirty="0">
                 <a:solidFill>
                   <a:srgbClr val="FFFFFF"/>
                 </a:solidFill>
               </a:rPr>
-              <a:t>The agent crosses on its own — no peeking</a:t>
-            </a:r>
-            <a:endParaRPr lang="en-US" sz="2800" dirty="0"/>
+              <a:t>A learned policy crosses on its own — no peeking</a:t>
+            </a:r>
+            <a:endParaRPr lang="en-US" sz="2600" dirty="0"/>
           </a:p>
         </p:txBody>
       </p:sp>
@@ -7261,14 +7469,14 @@
               <a:buChar char="•"/>
             </a:pPr>
             <a:r>
-              <a:rPr lang="en-US" sz="1200" dirty="0">
+              <a:rPr lang="en-US" sz="1100" dirty="0">
                 <a:solidFill>
                   <a:srgbClr val="FFFFFF"/>
                 </a:solidFill>
               </a:rPr>
-              <a:t>Velocity per vehicle from nearest-neighbour matching of boxes between frames (label-agnostic).</a:t>
-            </a:r>
-            <a:endParaRPr lang="en-US" sz="1200" dirty="0"/>
+              <a:t>Tabular Q-learning (rl/train.py) on an offline simulator built from the stored detections of all 30 highway chunks (27,000 frames), same geometry as the app.</a:t>
+            </a:r>
+            <a:endParaRPr lang="en-US" sz="1100" dirty="0"/>
           </a:p>
           <a:p>
             <a:pPr marL="177800" indent="-177800">
@@ -7279,14 +7487,14 @@
               <a:buChar char="•"/>
             </a:pPr>
             <a:r>
-              <a:rPr lang="en-US" sz="1200" dirty="0">
+              <a:rPr lang="en-US" sz="1100" dirty="0">
                 <a:solidFill>
                   <a:srgbClr val="FFFFFF"/>
                 </a:solidFill>
               </a:rPr>
-              <a:t>Hops to the next lane only if no box is predicted to overlap it within 0.65 s; dodges back if its own cell is threatened.</a:t>
-            </a:r>
-            <a:endParaRPr lang="en-US" sz="1200" dirty="0"/>
+              <a:t>State = time-to-arrival bins for this lane, the next two and the previous one + progress + cooldown; actions hold / hop / back. 9,000 episodes, 241 s on a laptop.</a:t>
+            </a:r>
+            <a:endParaRPr lang="en-US" sz="1100" dirty="0"/>
           </a:p>
           <a:p>
             <a:pPr marL="177800" indent="-177800">
@@ -7297,14 +7505,14 @@
               <a:buChar char="•"/>
             </a:pPr>
             <a:r>
-              <a:rPr lang="en-US" sz="1200" dirty="0">
+              <a:rPr lang="en-US" sz="1100" dirty="0">
                 <a:solidFill>
                   <a:srgbClr val="FFFFFF"/>
                 </a:solidFill>
               </a:rPr>
-              <a:t>Uses only the stored detections up to the current frame; boxes without an estimate are assumed at highway speed.</a:t>
-            </a:r>
-            <a:endParaRPr lang="en-US" sz="1200" dirty="0"/>
+              <a:t>Live: the browser computes the same state and looks up the Q-table; unseen states fall back to the rule-based agent (0.65 s look-ahead). Only detections up to the current frame.</a:t>
+            </a:r>
+            <a:endParaRPr lang="en-US" sz="1100" dirty="0"/>
           </a:p>
           <a:p>
             <a:pPr marL="177800" indent="-177800">
@@ -7315,14 +7523,14 @@
               <a:buChar char="•"/>
             </a:pPr>
             <a:r>
-              <a:rPr lang="en-US" sz="1200" dirty="0">
+              <a:rPr lang="en-US" sz="1100" dirty="0">
                 <a:solidFill>
                   <a:srgbClr val="FFFFFF"/>
                 </a:solidFill>
               </a:rPr>
-              <a:t>Crossed in 2.2 s on chunk_0003. On another run a semi (labelled bus, 74%) got it at 2.4 s — it is honest, not scripted.</a:t>
-            </a:r>
-            <a:endParaRPr lang="en-US" sz="1200" dirty="0"/>
+              <a:t>Every run logged to Weights &amp; Biases (project hop24-autopilot); policy.json exported as a W&amp;B artifact.</a:t>
+            </a:r>
+            <a:endParaRPr lang="en-US" sz="1100" dirty="0"/>
           </a:p>
         </p:txBody>
       </p:sp>
@@ -7381,7 +7589,7 @@
               <a:buNone/>
             </a:pPr>
             <a:r>
-              <a:rPr lang="en-US" sz="1000" dirty="0">
+              <a:rPr lang="en-US" sz="900" dirty="0">
                 <a:solidFill>
                   <a:srgbClr val="FFCC33"/>
                 </a:solidFill>
@@ -7389,45 +7597,342 @@
                 <a:ea typeface="Courier New" pitchFamily="34" charset="-122"/>
                 <a:cs typeface="Courier New" pitchFamily="34" charset="-120"/>
               </a:rPr>
-              <a:t>thought: next lane clear for 0.65 s → hop</a:t>
+              <a:t>RL · here clear · next 0.4s · +2 clear · back clear · lane 3/8 → hop   (HUD: AUTOPILOT · RL policy)</a:t>
+            </a:r>
+            <a:endParaRPr lang="en-US" sz="900" dirty="0"/>
+          </a:p>
+        </p:txBody>
+      </p:sp>
+      <p:sp>
+        <p:nvSpPr>
+          <p:cNvPr id="7" name="Card"/>
+          <p:cNvSpPr/>
+          <p:nvPr/>
+        </p:nvSpPr>
+        <p:spPr>
+          <a:xfrm>
+            <a:off x="457200" y="3794760"/>
+            <a:ext cx="1920240" cy="914400"/>
+          </a:xfrm>
+          <a:prstGeom prst="roundRect">
+            <a:avLst>
+              <a:gd name="adj" fmla="val 8000"/>
+            </a:avLst>
+          </a:prstGeom>
+          <a:solidFill>
+            <a:srgbClr val="121826"/>
+          </a:solidFill>
+          <a:ln w="9525">
+            <a:solidFill>
+              <a:srgbClr val="202A3D"/>
+            </a:solidFill>
+            <a:prstDash val="solid"/>
+          </a:ln>
+        </p:spPr>
+      </p:sp>
+      <p:sp>
+        <p:nvSpPr>
+          <p:cNvPr id="8" name="Stat"/>
+          <p:cNvSpPr txBox="1"/>
+          <p:nvPr/>
+        </p:nvSpPr>
+        <p:spPr>
+          <a:xfrm>
+            <a:off x="594360" y="3867912"/>
+            <a:ext cx="1645920" cy="411480"/>
+          </a:xfrm>
+          <a:prstGeom prst="rect">
+            <a:avLst/>
+          </a:prstGeom>
+          <a:noFill/>
+          <a:ln/>
+        </p:spPr>
+        <p:txBody>
+          <a:bodyPr wrap="square" lIns="0" tIns="0" rIns="0" bIns="0" rtlCol="0" anchor="ctr"/>
+          <a:lstStyle/>
+          <a:p>
+            <a:pPr indent="0" marL="0">
+              <a:buNone/>
+            </a:pPr>
+            <a:r>
+              <a:rPr lang="en-US" sz="2000" b="1" dirty="0">
+                <a:solidFill>
+                  <a:srgbClr val="4CD38A"/>
+                </a:solidFill>
+              </a:rPr>
+              <a:t>41% vs 39%</a:t>
+            </a:r>
+            <a:endParaRPr lang="en-US" sz="2000" dirty="0"/>
+          </a:p>
+        </p:txBody>
+      </p:sp>
+      <p:sp>
+        <p:nvSpPr>
+          <p:cNvPr id="9" name="Stat label"/>
+          <p:cNvSpPr txBox="1"/>
+          <p:nvPr/>
+        </p:nvSpPr>
+        <p:spPr>
+          <a:xfrm>
+            <a:off x="594360" y="4279392"/>
+            <a:ext cx="1645920" cy="393192"/>
+          </a:xfrm>
+          <a:prstGeom prst="rect">
+            <a:avLst/>
+          </a:prstGeom>
+          <a:noFill/>
+          <a:ln/>
+        </p:spPr>
+        <p:txBody>
+          <a:bodyPr wrap="square" lIns="0" tIns="0" rIns="0" bIns="0" rtlCol="0" anchor="t"/>
+          <a:lstStyle/>
+          <a:p>
+            <a:pPr indent="0" marL="0">
+              <a:buNone/>
+            </a:pPr>
+            <a:r>
+              <a:rPr lang="en-US" sz="900" dirty="0">
+                <a:solidFill>
+                  <a:srgbClr val="AEB6C4"/>
+                </a:solidFill>
+              </a:rPr>
+              <a:t>crossed, learned vs rule-based · 600 random starts, same seed, same 30 chunks</a:t>
+            </a:r>
+            <a:endParaRPr lang="en-US" sz="900" dirty="0"/>
+          </a:p>
+        </p:txBody>
+      </p:sp>
+      <p:sp>
+        <p:nvSpPr>
+          <p:cNvPr id="10" name="Card"/>
+          <p:cNvSpPr/>
+          <p:nvPr/>
+        </p:nvSpPr>
+        <p:spPr>
+          <a:xfrm>
+            <a:off x="2560320" y="3794760"/>
+            <a:ext cx="1920240" cy="914400"/>
+          </a:xfrm>
+          <a:prstGeom prst="roundRect">
+            <a:avLst>
+              <a:gd name="adj" fmla="val 8000"/>
+            </a:avLst>
+          </a:prstGeom>
+          <a:solidFill>
+            <a:srgbClr val="121826"/>
+          </a:solidFill>
+          <a:ln w="9525">
+            <a:solidFill>
+              <a:srgbClr val="202A3D"/>
+            </a:solidFill>
+            <a:prstDash val="solid"/>
+          </a:ln>
+        </p:spPr>
+      </p:sp>
+      <p:sp>
+        <p:nvSpPr>
+          <p:cNvPr id="11" name="Stat"/>
+          <p:cNvSpPr txBox="1"/>
+          <p:nvPr/>
+        </p:nvSpPr>
+        <p:spPr>
+          <a:xfrm>
+            <a:off x="2697480" y="3867912"/>
+            <a:ext cx="1645920" cy="411480"/>
+          </a:xfrm>
+          <a:prstGeom prst="rect">
+            <a:avLst/>
+          </a:prstGeom>
+          <a:noFill/>
+          <a:ln/>
+        </p:spPr>
+        <p:txBody>
+          <a:bodyPr wrap="square" lIns="0" tIns="0" rIns="0" bIns="0" rtlCol="0" anchor="ctr"/>
+          <a:lstStyle/>
+          <a:p>
+            <a:pPr indent="0" marL="0">
+              <a:buNone/>
+            </a:pPr>
+            <a:r>
+              <a:rPr lang="en-US" sz="2000" b="1" dirty="0">
+                <a:solidFill>
+                  <a:srgbClr val="4CD38A"/>
+                </a:solidFill>
+              </a:rPr>
+              <a:t>46% vs 31%</a:t>
+            </a:r>
+            <a:endParaRPr lang="en-US" sz="2000" dirty="0"/>
+          </a:p>
+        </p:txBody>
+      </p:sp>
+      <p:sp>
+        <p:nvSpPr>
+          <p:cNvPr id="12" name="Stat label"/>
+          <p:cNvSpPr txBox="1"/>
+          <p:nvPr/>
+        </p:nvSpPr>
+        <p:spPr>
+          <a:xfrm>
+            <a:off x="2697480" y="4279392"/>
+            <a:ext cx="1645920" cy="393192"/>
+          </a:xfrm>
+          <a:prstGeom prst="rect">
+            <a:avLst/>
+          </a:prstGeom>
+          <a:noFill/>
+          <a:ln/>
+        </p:spPr>
+        <p:txBody>
+          <a:bodyPr wrap="square" lIns="0" tIns="0" rIns="0" bIns="0" rtlCol="0" anchor="t"/>
+          <a:lstStyle/>
+          <a:p>
+            <a:pPr indent="0" marL="0">
+              <a:buNone/>
+            </a:pPr>
+            <a:r>
+              <a:rPr lang="en-US" sz="900" dirty="0">
+                <a:solidFill>
+                  <a:srgbClr val="AEB6C4"/>
+                </a:solidFill>
+              </a:rPr>
+              <a:t>on p1c2, the demo camera</a:t>
+            </a:r>
+            <a:endParaRPr lang="en-US" sz="900" dirty="0"/>
+          </a:p>
+        </p:txBody>
+      </p:sp>
+      <p:sp>
+        <p:nvSpPr>
+          <p:cNvPr id="13" name="Card"/>
+          <p:cNvSpPr/>
+          <p:nvPr/>
+        </p:nvSpPr>
+        <p:spPr>
+          <a:xfrm>
+            <a:off x="4663440" y="3794760"/>
+            <a:ext cx="1920240" cy="914400"/>
+          </a:xfrm>
+          <a:prstGeom prst="roundRect">
+            <a:avLst>
+              <a:gd name="adj" fmla="val 8000"/>
+            </a:avLst>
+          </a:prstGeom>
+          <a:solidFill>
+            <a:srgbClr val="121826"/>
+          </a:solidFill>
+          <a:ln w="9525">
+            <a:solidFill>
+              <a:srgbClr val="202A3D"/>
+            </a:solidFill>
+            <a:prstDash val="solid"/>
+          </a:ln>
+        </p:spPr>
+      </p:sp>
+      <p:sp>
+        <p:nvSpPr>
+          <p:cNvPr id="14" name="Stat"/>
+          <p:cNvSpPr txBox="1"/>
+          <p:nvPr/>
+        </p:nvSpPr>
+        <p:spPr>
+          <a:xfrm>
+            <a:off x="4800600" y="3867912"/>
+            <a:ext cx="1645920" cy="411480"/>
+          </a:xfrm>
+          <a:prstGeom prst="rect">
+            <a:avLst/>
+          </a:prstGeom>
+          <a:noFill/>
+          <a:ln/>
+        </p:spPr>
+        <p:txBody>
+          <a:bodyPr wrap="square" lIns="0" tIns="0" rIns="0" bIns="0" rtlCol="0" anchor="ctr"/>
+          <a:lstStyle/>
+          <a:p>
+            <a:pPr indent="0" marL="0">
+              <a:buNone/>
+            </a:pPr>
+            <a:r>
+              <a:rPr lang="en-US" sz="2000" b="1" dirty="0">
+                <a:solidFill>
+                  <a:srgbClr val="FF5A5F"/>
+                </a:solidFill>
+              </a:rPr>
+              <a:t>53% vs 64%</a:t>
+            </a:r>
+            <a:endParaRPr lang="en-US" sz="2000" dirty="0"/>
+          </a:p>
+        </p:txBody>
+      </p:sp>
+      <p:sp>
+        <p:nvSpPr>
+          <p:cNvPr id="15" name="Stat label"/>
+          <p:cNvSpPr txBox="1"/>
+          <p:nvPr/>
+        </p:nvSpPr>
+        <p:spPr>
+          <a:xfrm>
+            <a:off x="4800600" y="4279392"/>
+            <a:ext cx="1645920" cy="393192"/>
+          </a:xfrm>
+          <a:prstGeom prst="rect">
+            <a:avLst/>
+          </a:prstGeom>
+          <a:noFill/>
+          <a:ln/>
+        </p:spPr>
+        <p:txBody>
+          <a:bodyPr wrap="square" lIns="0" tIns="0" rIns="0" bIns="0" rtlCol="0" anchor="t"/>
+          <a:lstStyle/>
+          <a:p>
+            <a:pPr indent="0" marL="0">
+              <a:buNone/>
+            </a:pPr>
+            <a:r>
+              <a:rPr lang="en-US" sz="900" dirty="0">
+                <a:solidFill>
+                  <a:srgbClr val="AEB6C4"/>
+                </a:solidFill>
+              </a:rPr>
+              <a:t>on p1c3 — worse there; we say so</a:t>
+            </a:r>
+            <a:endParaRPr lang="en-US" sz="900" dirty="0"/>
+          </a:p>
+        </p:txBody>
+      </p:sp>
+      <p:sp>
+        <p:nvSpPr>
+          <p:cNvPr id="16" name="RL caveat"/>
+          <p:cNvSpPr txBox="1"/>
+          <p:nvPr/>
+        </p:nvSpPr>
+        <p:spPr>
+          <a:xfrm>
+            <a:off x="6766560" y="3794760"/>
+            <a:ext cx="1920240" cy="914400"/>
+          </a:xfrm>
+          <a:prstGeom prst="rect">
+            <a:avLst/>
+          </a:prstGeom>
+          <a:noFill/>
+          <a:ln/>
+        </p:spPr>
+        <p:txBody>
+          <a:bodyPr wrap="square" lIns="0" tIns="0" rIns="0" bIns="0" rtlCol="0" anchor="ctr"/>
+          <a:lstStyle/>
+          <a:p>
+            <a:pPr indent="0" marL="0">
+              <a:buNone/>
+            </a:pPr>
+            <a:r>
+              <a:rPr lang="en-US" sz="1000" i="1" dirty="0">
+                <a:solidFill>
+                  <a:srgbClr val="AEB6C4"/>
+                </a:solidFill>
+              </a:rPr>
+              <a:t>Modest overall gain; the per-camera split is the honest picture. It still dies sometimes.</a:t>
             </a:r>
             <a:endParaRPr lang="en-US" sz="1000" dirty="0"/>
-          </a:p>
-        </p:txBody>
-      </p:sp>
-      <p:sp>
-        <p:nvSpPr>
-          <p:cNvPr id="7" name="Caption"/>
-          <p:cNvSpPr txBox="1"/>
-          <p:nvPr/>
-        </p:nvSpPr>
-        <p:spPr>
-          <a:xfrm>
-            <a:off x="457200" y="4023360"/>
-            <a:ext cx="8229600" cy="274320"/>
-          </a:xfrm>
-          <a:prstGeom prst="rect">
-            <a:avLst/>
-          </a:prstGeom>
-          <a:noFill/>
-          <a:ln/>
-        </p:spPr>
-        <p:txBody>
-          <a:bodyPr wrap="square" lIns="0" tIns="0" rIns="0" bIns="0" rtlCol="0" anchor="ctr"/>
-          <a:lstStyle/>
-          <a:p>
-            <a:pPr indent="0" marL="0">
-              <a:buNone/>
-            </a:pPr>
-            <a:r>
-              <a:rPr lang="en-US" sz="900" i="1" dirty="0">
-                <a:solidFill>
-                  <a:srgbClr val="AEB6C4"/>
-                </a:solidFill>
-              </a:rPr>
-              <a:t>Policy: learned by Q-learning on an offline simulator built from the stored detections of all 30 highway chunks, training logged to Weights &amp; Biases; the rule-based agent is the fallback.</a:t>
-            </a:r>
-            <a:endParaRPr lang="en-US" sz="900" dirty="0"/>
           </a:p>
         </p:txBody>
       </p:sp>

</xml_diff>